<commit_message>
Potential Fix for slides with less than 6 images having leftover gradients
</commit_message>
<xml_diff>
--- a/Subject I - Build 4 Use AMO Reports/input/templates/Templates Slides.pptx
+++ b/Subject I - Build 4 Use AMO Reports/input/templates/Templates Slides.pptx
@@ -149,6 +149,66 @@
 </p:presentation>
 </file>
 
+<file path=ppt/changesInfos/changesInfo1.xml><?xml version="1.0" encoding="utf-8"?>
+<pc:chgInfo xmlns:a="http://schemas.openxmlformats.org/drawingml/2006/main" xmlns:r="http://schemas.openxmlformats.org/officeDocument/2006/relationships" xmlns:ac="http://schemas.microsoft.com/office/drawing/2013/main/command" xmlns:pc="http://schemas.microsoft.com/office/powerpoint/2013/main/command">
+  <pc:docChgLst>
+    <pc:chgData name="Octave CINQUANTA" userId="89c3e02c-f1c9-446e-b6f9-21fb849d67d7" providerId="ADAL" clId="{A9C6C70A-4628-4C71-9FB0-62B06E5840EB}"/>
+    <pc:docChg chg="custSel modSld">
+      <pc:chgData name="Octave CINQUANTA" userId="89c3e02c-f1c9-446e-b6f9-21fb849d67d7" providerId="ADAL" clId="{A9C6C70A-4628-4C71-9FB0-62B06E5840EB}" dt="2026-04-03T07:44:47.368" v="4" actId="478"/>
+      <pc:docMkLst>
+        <pc:docMk/>
+      </pc:docMkLst>
+      <pc:sldChg chg="delSp modSp mod">
+        <pc:chgData name="Octave CINQUANTA" userId="89c3e02c-f1c9-446e-b6f9-21fb849d67d7" providerId="ADAL" clId="{A9C6C70A-4628-4C71-9FB0-62B06E5840EB}" dt="2026-04-03T07:44:43.969" v="2" actId="478"/>
+        <pc:sldMkLst>
+          <pc:docMk/>
+          <pc:sldMk cId="3961354135" sldId="435"/>
+        </pc:sldMkLst>
+        <pc:spChg chg="del">
+          <ac:chgData name="Octave CINQUANTA" userId="89c3e02c-f1c9-446e-b6f9-21fb849d67d7" providerId="ADAL" clId="{A9C6C70A-4628-4C71-9FB0-62B06E5840EB}" dt="2026-04-03T07:44:39.295" v="0" actId="478"/>
+          <ac:spMkLst>
+            <pc:docMk/>
+            <pc:sldMk cId="3961354135" sldId="435"/>
+            <ac:spMk id="10" creationId="{EB3639AD-7626-DBA9-6ECA-F4C282BD0CFD}"/>
+          </ac:spMkLst>
+        </pc:spChg>
+        <pc:spChg chg="del mod">
+          <ac:chgData name="Octave CINQUANTA" userId="89c3e02c-f1c9-446e-b6f9-21fb849d67d7" providerId="ADAL" clId="{A9C6C70A-4628-4C71-9FB0-62B06E5840EB}" dt="2026-04-03T07:44:43.969" v="2" actId="478"/>
+          <ac:spMkLst>
+            <pc:docMk/>
+            <pc:sldMk cId="3961354135" sldId="435"/>
+            <ac:spMk id="14" creationId="{4E97CD34-5C3C-299E-4141-5785B8F245D9}"/>
+          </ac:spMkLst>
+        </pc:spChg>
+      </pc:sldChg>
+      <pc:sldChg chg="delSp mod">
+        <pc:chgData name="Octave CINQUANTA" userId="89c3e02c-f1c9-446e-b6f9-21fb849d67d7" providerId="ADAL" clId="{A9C6C70A-4628-4C71-9FB0-62B06E5840EB}" dt="2026-04-03T07:44:47.368" v="4" actId="478"/>
+        <pc:sldMkLst>
+          <pc:docMk/>
+          <pc:sldMk cId="1196296059" sldId="483"/>
+        </pc:sldMkLst>
+        <pc:spChg chg="del">
+          <ac:chgData name="Octave CINQUANTA" userId="89c3e02c-f1c9-446e-b6f9-21fb849d67d7" providerId="ADAL" clId="{A9C6C70A-4628-4C71-9FB0-62B06E5840EB}" dt="2026-04-03T07:44:46.238" v="3" actId="478"/>
+          <ac:spMkLst>
+            <pc:docMk/>
+            <pc:sldMk cId="1196296059" sldId="483"/>
+            <ac:spMk id="10" creationId="{D620E9BC-5027-4638-034C-147681D392BD}"/>
+          </ac:spMkLst>
+        </pc:spChg>
+        <pc:spChg chg="del">
+          <ac:chgData name="Octave CINQUANTA" userId="89c3e02c-f1c9-446e-b6f9-21fb849d67d7" providerId="ADAL" clId="{A9C6C70A-4628-4C71-9FB0-62B06E5840EB}" dt="2026-04-03T07:44:47.368" v="4" actId="478"/>
+          <ac:spMkLst>
+            <pc:docMk/>
+            <pc:sldMk cId="1196296059" sldId="483"/>
+            <ac:spMk id="14" creationId="{9228B391-C909-6A1D-6412-AFC1D2C9DC19}"/>
+          </ac:spMkLst>
+        </pc:spChg>
+      </pc:sldChg>
+    </pc:docChg>
+  </pc:docChgLst>
+</pc:chgInfo>
+</file>
+
 <file path=ppt/handoutMasters/handoutMaster1.xml><?xml version="1.0" encoding="utf-8"?>
 <p:handoutMaster xmlns:a="http://schemas.openxmlformats.org/drawingml/2006/main" xmlns:r="http://schemas.openxmlformats.org/officeDocument/2006/relationships" xmlns:p="http://schemas.openxmlformats.org/presentationml/2006/main">
   <p:cSld>
@@ -243,7 +303,7 @@
           <a:p>
             <a:fld id="{CA582855-BA57-4003-9446-17B85183D854}" type="datetimeFigureOut">
               <a:rPr lang="fr-FR" smtClean="0"/>
-              <a:t>11/03/2026</a:t>
+              <a:t>03/04/2026</a:t>
             </a:fld>
             <a:endParaRPr lang="fr-FR" dirty="0"/>
           </a:p>
@@ -420,7 +480,7 @@
           <a:p>
             <a:fld id="{59E8E742-30BA-4E0C-9FF8-35B9CEFE9EC2}" type="datetimeFigureOut">
               <a:rPr lang="fr-FR" smtClean="0"/>
-              <a:t>11/03/2026</a:t>
+              <a:t>03/04/2026</a:t>
             </a:fld>
             <a:endParaRPr lang="fr-FR" dirty="0"/>
           </a:p>
@@ -1874,10 +1934,10 @@
           <p:nvPr userDrawn="1"/>
         </p:nvPicPr>
         <p:blipFill>
-          <a:blip r:embed="rId6">
+          <a:blip>
             <a:extLst>
               <a:ext uri="{96DAC541-7B7A-43D3-8B79-37D633B846F1}">
-                <asvg:svgBlip xmlns:asvg="http://schemas.microsoft.com/office/drawing/2016/SVG/main" r:embed="rId7"/>
+                <asvg:svgBlip xmlns:asvg="http://schemas.microsoft.com/office/drawing/2016/SVG/main" r:embed="rId6"/>
               </a:ext>
             </a:extLst>
           </a:blip>
@@ -8880,60 +8940,6 @@
       </p:sp>
       <p:sp>
         <p:nvSpPr>
-          <p:cNvPr id="10" name="Rectangle: Rounded Corners 7">
-            <a:extLst>
-              <a:ext uri="{FF2B5EF4-FFF2-40B4-BE49-F238E27FC236}">
-                <a16:creationId xmlns:a16="http://schemas.microsoft.com/office/drawing/2014/main" id="{EB3639AD-7626-DBA9-6ECA-F4C282BD0CFD}"/>
-              </a:ext>
-            </a:extLst>
-          </p:cNvPr>
-          <p:cNvSpPr/>
-          <p:nvPr/>
-        </p:nvSpPr>
-        <p:spPr>
-          <a:xfrm>
-            <a:off x="5369917" y="1047294"/>
-            <a:ext cx="3213659" cy="1419220"/>
-          </a:xfrm>
-          <a:prstGeom prst="roundRect">
-            <a:avLst>
-              <a:gd name="adj" fmla="val 25123"/>
-            </a:avLst>
-          </a:prstGeom>
-          <a:solidFill>
-            <a:schemeClr val="tx1"/>
-          </a:solidFill>
-          <a:ln>
-            <a:noFill/>
-          </a:ln>
-        </p:spPr>
-        <p:style>
-          <a:lnRef idx="2">
-            <a:schemeClr val="accent1">
-              <a:shade val="50000"/>
-            </a:schemeClr>
-          </a:lnRef>
-          <a:fillRef idx="1">
-            <a:schemeClr val="accent1"/>
-          </a:fillRef>
-          <a:effectRef idx="0">
-            <a:schemeClr val="accent1"/>
-          </a:effectRef>
-          <a:fontRef idx="minor">
-            <a:schemeClr val="lt1"/>
-          </a:fontRef>
-        </p:style>
-        <p:txBody>
-          <a:bodyPr rtlCol="0" anchor="ctr"/>
-          <a:lstStyle/>
-          <a:p>
-            <a:pPr algn="ctr"/>
-            <a:endParaRPr lang="id-ID" sz="1350"/>
-          </a:p>
-        </p:txBody>
-      </p:sp>
-      <p:sp>
-        <p:nvSpPr>
           <p:cNvPr id="12" name="TextBox 72">
             <a:extLst>
               <a:ext uri="{FF2B5EF4-FFF2-40B4-BE49-F238E27FC236}">
@@ -8977,48 +8983,6 @@
               <a:latin typeface="+mj-lt"/>
               <a:cs typeface="Poppins" panose="00000800000000000000" pitchFamily="2" charset="0"/>
             </a:endParaRPr>
-          </a:p>
-        </p:txBody>
-      </p:sp>
-      <p:sp>
-        <p:nvSpPr>
-          <p:cNvPr id="14" name="ZoneTexte 13">
-            <a:extLst>
-              <a:ext uri="{FF2B5EF4-FFF2-40B4-BE49-F238E27FC236}">
-                <a16:creationId xmlns:a16="http://schemas.microsoft.com/office/drawing/2014/main" id="{4E97CD34-5C3C-299E-4141-5785B8F245D9}"/>
-              </a:ext>
-            </a:extLst>
-          </p:cNvPr>
-          <p:cNvSpPr txBox="1"/>
-          <p:nvPr/>
-        </p:nvSpPr>
-        <p:spPr>
-          <a:xfrm>
-            <a:off x="5539923" y="1156739"/>
-            <a:ext cx="1416966" cy="1200329"/>
-          </a:xfrm>
-          <a:prstGeom prst="rect">
-            <a:avLst/>
-          </a:prstGeom>
-          <a:noFill/>
-        </p:spPr>
-        <p:txBody>
-          <a:bodyPr wrap="square">
-            <a:spAutoFit/>
-          </a:bodyPr>
-          <a:lstStyle/>
-          <a:p>
-            <a:r>
-              <a:rPr lang="fr-FR" sz="3600" dirty="0">
-                <a:solidFill>
-                  <a:srgbClr val="FF5C19"/>
-                </a:solidFill>
-                <a:latin typeface="+mj-lt"/>
-                <a:sym typeface="Montserrat"/>
-              </a:rPr>
-              <a:t>Info Clé</a:t>
-            </a:r>
-            <a:endParaRPr lang="fr-FR" sz="3600" noProof="0" dirty="0"/>
           </a:p>
         </p:txBody>
       </p:sp>
@@ -15495,102 +15459,6 @@
               <a:ea typeface="Aptos" panose="020B0004020202020204" pitchFamily="34" charset="0"/>
               <a:cs typeface="Times New Roman" panose="02020603050405020304" pitchFamily="18" charset="0"/>
             </a:endParaRPr>
-          </a:p>
-        </p:txBody>
-      </p:sp>
-      <p:sp>
-        <p:nvSpPr>
-          <p:cNvPr id="10" name="Rectangle: Rounded Corners 7">
-            <a:extLst>
-              <a:ext uri="{FF2B5EF4-FFF2-40B4-BE49-F238E27FC236}">
-                <a16:creationId xmlns:a16="http://schemas.microsoft.com/office/drawing/2014/main" id="{D620E9BC-5027-4638-034C-147681D392BD}"/>
-              </a:ext>
-            </a:extLst>
-          </p:cNvPr>
-          <p:cNvSpPr/>
-          <p:nvPr/>
-        </p:nvSpPr>
-        <p:spPr>
-          <a:xfrm>
-            <a:off x="5369917" y="1047294"/>
-            <a:ext cx="3213659" cy="1419220"/>
-          </a:xfrm>
-          <a:prstGeom prst="roundRect">
-            <a:avLst>
-              <a:gd name="adj" fmla="val 25123"/>
-            </a:avLst>
-          </a:prstGeom>
-          <a:solidFill>
-            <a:schemeClr val="tx1"/>
-          </a:solidFill>
-          <a:ln>
-            <a:noFill/>
-          </a:ln>
-        </p:spPr>
-        <p:style>
-          <a:lnRef idx="2">
-            <a:schemeClr val="accent1">
-              <a:shade val="50000"/>
-            </a:schemeClr>
-          </a:lnRef>
-          <a:fillRef idx="1">
-            <a:schemeClr val="accent1"/>
-          </a:fillRef>
-          <a:effectRef idx="0">
-            <a:schemeClr val="accent1"/>
-          </a:effectRef>
-          <a:fontRef idx="minor">
-            <a:schemeClr val="lt1"/>
-          </a:fontRef>
-        </p:style>
-        <p:txBody>
-          <a:bodyPr rtlCol="0" anchor="ctr"/>
-          <a:lstStyle/>
-          <a:p>
-            <a:pPr algn="ctr"/>
-            <a:endParaRPr lang="id-ID" sz="1350"/>
-          </a:p>
-        </p:txBody>
-      </p:sp>
-      <p:sp>
-        <p:nvSpPr>
-          <p:cNvPr id="14" name="ZoneTexte 13">
-            <a:extLst>
-              <a:ext uri="{FF2B5EF4-FFF2-40B4-BE49-F238E27FC236}">
-                <a16:creationId xmlns:a16="http://schemas.microsoft.com/office/drawing/2014/main" id="{9228B391-C909-6A1D-6412-AFC1D2C9DC19}"/>
-              </a:ext>
-            </a:extLst>
-          </p:cNvPr>
-          <p:cNvSpPr txBox="1"/>
-          <p:nvPr/>
-        </p:nvSpPr>
-        <p:spPr>
-          <a:xfrm>
-            <a:off x="5350867" y="1530514"/>
-            <a:ext cx="3213658" cy="523220"/>
-          </a:xfrm>
-          <a:prstGeom prst="rect">
-            <a:avLst/>
-          </a:prstGeom>
-          <a:noFill/>
-        </p:spPr>
-        <p:txBody>
-          <a:bodyPr wrap="square">
-            <a:spAutoFit/>
-          </a:bodyPr>
-          <a:lstStyle/>
-          <a:p>
-            <a:pPr algn="ctr"/>
-            <a:r>
-              <a:rPr lang="fr-FR" sz="2800" dirty="0">
-                <a:solidFill>
-                  <a:srgbClr val="FF5C19"/>
-                </a:solidFill>
-                <a:sym typeface="Montserrat"/>
-              </a:rPr>
-              <a:t>Info Clé</a:t>
-            </a:r>
-            <a:endParaRPr lang="fr-FR" sz="2800" dirty="0"/>
           </a:p>
         </p:txBody>
       </p:sp>
@@ -16549,6 +16417,26 @@
 </file>
 
 <file path=customXml/item1.xml><?xml version="1.0" encoding="utf-8"?>
+<?mso-contentType ?>
+<FormTemplates xmlns="http://schemas.microsoft.com/sharepoint/v3/contenttype/forms">
+  <Display>DocumentLibraryForm</Display>
+  <Edit>DocumentLibraryForm</Edit>
+  <New>DocumentLibraryForm</New>
+</FormTemplates>
+</file>
+
+<file path=customXml/item2.xml><?xml version="1.0" encoding="utf-8"?>
+<p:properties xmlns:p="http://schemas.microsoft.com/office/2006/metadata/properties" xmlns:xsi="http://www.w3.org/2001/XMLSchema-instance" xmlns:pc="http://schemas.microsoft.com/office/infopath/2007/PartnerControls">
+  <documentManagement>
+    <TaxCatchAll xmlns="17d7cf28-00fc-4e86-a149-804d1839a458" xsi:nil="true"/>
+    <lcf76f155ced4ddcb4097134ff3c332f xmlns="bf0a6765-dc68-4f24-bddf-c349c0756815">
+      <Terms xmlns="http://schemas.microsoft.com/office/infopath/2007/PartnerControls"/>
+    </lcf76f155ced4ddcb4097134ff3c332f>
+  </documentManagement>
+</p:properties>
+</file>
+
+<file path=customXml/item3.xml><?xml version="1.0" encoding="utf-8"?>
 <ct:contentTypeSchema xmlns:ct="http://schemas.microsoft.com/office/2006/metadata/contentType" xmlns:ma="http://schemas.microsoft.com/office/2006/metadata/properties/metaAttributes" ct:_="" ma:_="" ma:contentTypeName="Document" ma:contentTypeID="0x0101001A5DB79A98ABF248B903CEC03EA44FE8" ma:contentTypeVersion="13" ma:contentTypeDescription="Crée un document." ma:contentTypeScope="" ma:versionID="eabca4f27a9c3130bef6b4c261ef1751">
   <xsd:schema xmlns:xsd="http://www.w3.org/2001/XMLSchema" xmlns:xs="http://www.w3.org/2001/XMLSchema" xmlns:p="http://schemas.microsoft.com/office/2006/metadata/properties" xmlns:ns2="bf0a6765-dc68-4f24-bddf-c349c0756815" xmlns:ns3="17d7cf28-00fc-4e86-a149-804d1839a458" targetNamespace="http://schemas.microsoft.com/office/2006/metadata/properties" ma:root="true" ma:fieldsID="52352792db4dc5773d4c2bf08be5aad2" ns2:_="" ns3:_="">
     <xsd:import namespace="bf0a6765-dc68-4f24-bddf-c349c0756815"/>
@@ -16755,28 +16643,12 @@
 </ct:contentTypeSchema>
 </file>
 
-<file path=customXml/item2.xml><?xml version="1.0" encoding="utf-8"?>
-<p:properties xmlns:p="http://schemas.microsoft.com/office/2006/metadata/properties" xmlns:xsi="http://www.w3.org/2001/XMLSchema-instance" xmlns:pc="http://schemas.microsoft.com/office/infopath/2007/PartnerControls">
-  <documentManagement>
-    <TaxCatchAll xmlns="17d7cf28-00fc-4e86-a149-804d1839a458" xsi:nil="true"/>
-    <lcf76f155ced4ddcb4097134ff3c332f xmlns="bf0a6765-dc68-4f24-bddf-c349c0756815">
-      <Terms xmlns="http://schemas.microsoft.com/office/infopath/2007/PartnerControls"/>
-    </lcf76f155ced4ddcb4097134ff3c332f>
-  </documentManagement>
-</p:properties>
-</file>
-
-<file path=customXml/item3.xml><?xml version="1.0" encoding="utf-8"?>
-<?mso-contentType ?>
-<FormTemplates xmlns="http://schemas.microsoft.com/sharepoint/v3/contenttype/forms">
-  <Display>DocumentLibraryForm</Display>
-  <Edit>DocumentLibraryForm</Edit>
-  <New>DocumentLibraryForm</New>
-</FormTemplates>
-</file>
-
 <file path=customXml/itemProps1.xml><?xml version="1.0" encoding="utf-8"?>
-<ds:datastoreItem xmlns:ds="http://schemas.openxmlformats.org/officeDocument/2006/customXml" ds:itemID="{9D1B7BCE-E28F-4E50-B27B-B5DD958438EC}"/>
+<ds:datastoreItem xmlns:ds="http://schemas.openxmlformats.org/officeDocument/2006/customXml" ds:itemID="{1BEB67FF-486C-44E7-A3C3-F8A046E86188}">
+  <ds:schemaRefs>
+    <ds:schemaRef ds:uri="http://schemas.microsoft.com/sharepoint/v3/contenttype/forms"/>
+  </ds:schemaRefs>
+</ds:datastoreItem>
 </file>
 
 <file path=customXml/itemProps2.xml><?xml version="1.0" encoding="utf-8"?>
@@ -16792,14 +16664,26 @@
     <ds:schemaRef ds:uri="c71efbff-53c5-4d70-aa29-28c7c2c6b442"/>
     <ds:schemaRef ds:uri="http://schemas.microsoft.com/office/2006/metadata/properties"/>
     <ds:schemaRef ds:uri="http://purl.org/dc/dcmitype/"/>
+    <ds:schemaRef ds:uri="bf0a6765-dc68-4f24-bddf-c349c0756815"/>
   </ds:schemaRefs>
 </ds:datastoreItem>
 </file>
 
 <file path=customXml/itemProps3.xml><?xml version="1.0" encoding="utf-8"?>
-<ds:datastoreItem xmlns:ds="http://schemas.openxmlformats.org/officeDocument/2006/customXml" ds:itemID="{1BEB67FF-486C-44E7-A3C3-F8A046E86188}">
+<ds:datastoreItem xmlns:ds="http://schemas.openxmlformats.org/officeDocument/2006/customXml" ds:itemID="{9D1B7BCE-E28F-4E50-B27B-B5DD958438EC}">
   <ds:schemaRefs>
-    <ds:schemaRef ds:uri="http://schemas.microsoft.com/sharepoint/v3/contenttype/forms"/>
+    <ds:schemaRef ds:uri="http://schemas.microsoft.com/office/2006/metadata/contentType"/>
+    <ds:schemaRef ds:uri="http://schemas.microsoft.com/office/2006/metadata/properties/metaAttributes"/>
+    <ds:schemaRef ds:uri="http://www.w3.org/2001/XMLSchema"/>
+    <ds:schemaRef ds:uri="http://schemas.microsoft.com/office/2006/metadata/properties"/>
+    <ds:schemaRef ds:uri="bf0a6765-dc68-4f24-bddf-c349c0756815"/>
+    <ds:schemaRef ds:uri="17d7cf28-00fc-4e86-a149-804d1839a458"/>
+    <ds:schemaRef ds:uri="http://schemas.microsoft.com/office/2006/documentManagement/types"/>
+    <ds:schemaRef ds:uri="http://schemas.microsoft.com/office/infopath/2007/PartnerControls"/>
+    <ds:schemaRef ds:uri="http://schemas.openxmlformats.org/package/2006/metadata/core-properties"/>
+    <ds:schemaRef ds:uri="http://purl.org/dc/elements/1.1/"/>
+    <ds:schemaRef ds:uri="http://purl.org/dc/terms/"/>
+    <ds:schemaRef ds:uri="http://schemas.microsoft.com/internal/obd"/>
   </ds:schemaRefs>
 </ds:datastoreItem>
 </file>
</xml_diff>